<commit_message>
Redesign technical approach slide with verified workflow
</commit_message>
<xml_diff>
--- a/docs/submission/SIH2026-PS26250-AIR-COMMAND.pptx
+++ b/docs/submission/SIH2026-PS26250-AIR-COMMAND.pptx
@@ -6523,8 +6523,8 @@
         </p:nvSpPr>
         <p:spPr>
           <a:xfrm>
-            <a:off x="612648" y="1874519"/>
-            <a:ext cx="5074920" cy="4297680"/>
+            <a:off x="612648" y="1115568"/>
+            <a:ext cx="10972800" cy="274320"/>
           </a:xfrm>
           <a:prstGeom prst="rect">
             <a:avLst/>
@@ -6532,110 +6532,498 @@
           <a:noFill/>
         </p:spPr>
         <p:txBody>
-          <a:bodyPr wrap="square" lIns="18288" rIns="36576" tIns="18288" bIns="18288">
+          <a:bodyPr wrap="none" lIns="0" rIns="0" tIns="0" bIns="0">
             <a:spAutoFit/>
           </a:bodyPr>
           <a:lstStyle/>
           <a:p>
             <a:pPr>
-              <a:spcAft>
-                <a:spcPts val="900"/>
-              </a:spcAft>
-              <a:defRPr sz="1800" b="1">
-                <a:solidFill>
-                  <a:srgbClr val="224D80"/>
+              <a:defRPr sz="1400">
+                <a:solidFill>
+                  <a:srgbClr val="546370"/>
                 </a:solidFill>
                 <a:latin typeface="Arial"/>
               </a:defRPr>
             </a:pPr>
             <a:r>
-              <a:t>Svelte 5 + TypeScript browser application</a:t>
-            </a:r>
-          </a:p>
+              <a:t>Browser prototype  |  Local exercise data  |  Human-reviewed recommendations</a:t>
+            </a:r>
+          </a:p>
+        </p:txBody>
+      </p:sp>
+      <p:sp>
+        <p:nvSpPr>
+          <p:cNvPr id="17411" name="TextBox 17410"/>
+          <p:cNvSpPr txBox="1"/>
+          <p:nvPr/>
+        </p:nvSpPr>
+        <p:spPr>
+          <a:xfrm>
+            <a:off x="612648" y="1444752"/>
+            <a:ext cx="5303520" cy="256032"/>
+          </a:xfrm>
+          <a:prstGeom prst="rect">
+            <a:avLst/>
+          </a:prstGeom>
+          <a:noFill/>
+        </p:spPr>
+        <p:txBody>
+          <a:bodyPr wrap="none" lIns="0" rIns="0" tIns="0" bIns="0">
+            <a:spAutoFit/>
+          </a:bodyPr>
+          <a:lstStyle/>
+          <a:p>
+            <a:pPr>
+              <a:defRPr sz="1300" b="1">
+                <a:solidFill>
+                  <a:srgbClr val="224D80"/>
+                </a:solidFill>
+                <a:latin typeface="Arial"/>
+              </a:defRPr>
+            </a:pPr>
+            <a:r>
+              <a:t>APPLICATION FLOW</a:t>
+            </a:r>
+          </a:p>
+        </p:txBody>
+      </p:sp>
+      <p:cxnSp>
+        <p:nvCxnSpPr>
+          <p:cNvPr id="17412" name="Connector 17411"/>
+          <p:cNvCxnSpPr/>
+          <p:nvPr/>
+        </p:nvCxnSpPr>
+        <p:spPr>
+          <a:xfrm>
+            <a:off x="868680" y="1965960"/>
+            <a:ext cx="0" cy="3611880"/>
+          </a:xfrm>
+          <a:prstGeom prst="line">
+            <a:avLst/>
+          </a:prstGeom>
+          <a:ln w="25400">
+            <a:solidFill>
+              <a:srgbClr val="DAE4EC"/>
+            </a:solidFill>
+          </a:ln>
+        </p:spPr>
+        <p:style>
+          <a:lnRef idx="2">
+            <a:schemeClr val="accent1"/>
+          </a:lnRef>
+          <a:fillRef idx="0">
+            <a:schemeClr val="accent1"/>
+          </a:fillRef>
+          <a:effectRef idx="1">
+            <a:schemeClr val="accent1"/>
+          </a:effectRef>
+          <a:fontRef idx="minor">
+            <a:schemeClr val="tx1"/>
+          </a:fontRef>
+        </p:style>
+      </p:cxnSp>
+      <p:sp>
+        <p:nvSpPr>
+          <p:cNvPr id="17413" name="Oval 17412"/>
+          <p:cNvSpPr/>
+          <p:nvPr/>
+        </p:nvSpPr>
+        <p:spPr>
+          <a:xfrm>
+            <a:off x="676656" y="1773936"/>
+            <a:ext cx="384048" cy="384048"/>
+          </a:xfrm>
+          <a:prstGeom prst="ellipse">
+            <a:avLst/>
+          </a:prstGeom>
+          <a:solidFill>
+            <a:srgbClr val="224D80"/>
+          </a:solidFill>
+          <a:ln>
+            <a:noFill/>
+          </a:ln>
+        </p:spPr>
+        <p:style>
+          <a:lnRef idx="1">
+            <a:schemeClr val="accent1"/>
+          </a:lnRef>
+          <a:fillRef idx="3">
+            <a:schemeClr val="accent1"/>
+          </a:fillRef>
+          <a:effectRef idx="2">
+            <a:schemeClr val="accent1"/>
+          </a:effectRef>
+          <a:fontRef idx="minor">
+            <a:schemeClr val="lt1"/>
+          </a:fontRef>
+        </p:style>
+        <p:txBody>
+          <a:bodyPr rtlCol="0" anchor="ctr" lIns="0" rIns="0" tIns="0" bIns="0"/>
+          <a:lstStyle/>
+          <a:p>
+            <a:pPr algn="ctr">
+              <a:defRPr sz="1100" b="1">
+                <a:solidFill>
+                  <a:srgbClr val="FFFFFF"/>
+                </a:solidFill>
+                <a:latin typeface="Arial"/>
+              </a:defRPr>
+            </a:pPr>
+            <a:r>
+              <a:t>01</a:t>
+            </a:r>
+          </a:p>
+        </p:txBody>
+      </p:sp>
+      <p:sp>
+        <p:nvSpPr>
+          <p:cNvPr id="17414" name="TextBox 17413"/>
+          <p:cNvSpPr txBox="1"/>
+          <p:nvPr/>
+        </p:nvSpPr>
+        <p:spPr>
+          <a:xfrm>
+            <a:off x="1225296" y="1764792"/>
+            <a:ext cx="4617720" cy="694944"/>
+          </a:xfrm>
+          <a:prstGeom prst="rect">
+            <a:avLst/>
+          </a:prstGeom>
+          <a:noFill/>
+        </p:spPr>
+        <p:txBody>
+          <a:bodyPr wrap="square" lIns="0" rIns="0" tIns="0" bIns="0">
+            <a:spAutoFit/>
+          </a:bodyPr>
+          <a:lstStyle/>
           <a:p>
             <a:pPr>
               <a:spcAft>
-                <a:spcPts val="400"/>
+                <a:spcPts val="200"/>
               </a:spcAft>
-              <a:defRPr sz="1500" b="0">
-                <a:solidFill>
-                  <a:srgbClr val="1A2836"/>
+              <a:defRPr sz="1300" b="1">
+                <a:solidFill>
+                  <a:srgbClr val="224D80"/>
                 </a:solidFill>
                 <a:latin typeface="Arial"/>
               </a:defRPr>
             </a:pPr>
             <a:r>
-              <a:t>Seeded scenario data models fleet, missions, threats, airspace, weather and weapon inventory.</a:t>
+              <a:t>EXERCISE INPUTS</a:t>
             </a:r>
           </a:p>
           <a:p>
             <a:pPr>
               <a:spcAft>
-                <a:spcPts val="400"/>
+                <a:spcPts val="0"/>
               </a:spcAft>
-              <a:defRPr sz="1500" b="0">
-                <a:solidFill>
-                  <a:srgbClr val="1A2836"/>
+              <a:defRPr sz="1150">
+                <a:solidFill>
+                  <a:srgbClr val="202B36"/>
                 </a:solidFill>
                 <a:latin typeface="Arial"/>
               </a:defRPr>
             </a:pPr>
             <a:r>
-              <a:t>Weighted rules rank aggressive, balanced and conservative courses of action.</a:t>
-            </a:r>
-          </a:p>
+              <a:t>Seeded aircraft, missions, threats, weapons, airspace and weather.</a:t>
+            </a:r>
+          </a:p>
+        </p:txBody>
+      </p:sp>
+      <p:sp>
+        <p:nvSpPr>
+          <p:cNvPr id="17415" name="Oval 17414"/>
+          <p:cNvSpPr/>
+          <p:nvPr/>
+        </p:nvSpPr>
+        <p:spPr>
+          <a:xfrm>
+            <a:off x="676656" y="2496312"/>
+            <a:ext cx="384048" cy="384048"/>
+          </a:xfrm>
+          <a:prstGeom prst="ellipse">
+            <a:avLst/>
+          </a:prstGeom>
+          <a:solidFill>
+            <a:srgbClr val="224D80"/>
+          </a:solidFill>
+          <a:ln>
+            <a:noFill/>
+          </a:ln>
+        </p:spPr>
+        <p:style>
+          <a:lnRef idx="1">
+            <a:schemeClr val="accent1"/>
+          </a:lnRef>
+          <a:fillRef idx="3">
+            <a:schemeClr val="accent1"/>
+          </a:fillRef>
+          <a:effectRef idx="2">
+            <a:schemeClr val="accent1"/>
+          </a:effectRef>
+          <a:fontRef idx="minor">
+            <a:schemeClr val="lt1"/>
+          </a:fontRef>
+        </p:style>
+        <p:txBody>
+          <a:bodyPr rtlCol="0" anchor="ctr" lIns="0" rIns="0" tIns="0" bIns="0"/>
+          <a:lstStyle/>
+          <a:p>
+            <a:pPr algn="ctr">
+              <a:defRPr sz="1100" b="1">
+                <a:solidFill>
+                  <a:srgbClr val="FFFFFF"/>
+                </a:solidFill>
+                <a:latin typeface="Arial"/>
+              </a:defRPr>
+            </a:pPr>
+            <a:r>
+              <a:t>02</a:t>
+            </a:r>
+          </a:p>
+        </p:txBody>
+      </p:sp>
+      <p:sp>
+        <p:nvSpPr>
+          <p:cNvPr id="17416" name="TextBox 17415"/>
+          <p:cNvSpPr txBox="1"/>
+          <p:nvPr/>
+        </p:nvSpPr>
+        <p:spPr>
+          <a:xfrm>
+            <a:off x="1225296" y="2487168"/>
+            <a:ext cx="4617720" cy="694944"/>
+          </a:xfrm>
+          <a:prstGeom prst="rect">
+            <a:avLst/>
+          </a:prstGeom>
+          <a:noFill/>
+        </p:spPr>
+        <p:txBody>
+          <a:bodyPr wrap="square" lIns="0" rIns="0" tIns="0" bIns="0">
+            <a:spAutoFit/>
+          </a:bodyPr>
+          <a:lstStyle/>
           <a:p>
             <a:pPr>
               <a:spcAft>
-                <a:spcPts val="400"/>
+                <a:spcPts val="200"/>
               </a:spcAft>
-              <a:defRPr sz="1500" b="0">
-                <a:solidFill>
-                  <a:srgbClr val="1A2836"/>
+              <a:defRPr sz="1300" b="1">
+                <a:solidFill>
+                  <a:srgbClr val="224D80"/>
                 </a:solidFill>
                 <a:latin typeface="Arial"/>
               </a:defRPr>
             </a:pPr>
             <a:r>
-              <a:t>Filters check readiness, fuel, crew rest, weapon compatibility and range, route exposure, closed airspace and weather thresholds.</a:t>
+              <a:t>SCENARIO VIEW</a:t>
             </a:r>
           </a:p>
           <a:p>
             <a:pPr>
               <a:spcAft>
-                <a:spcPts val="400"/>
+                <a:spcPts val="0"/>
               </a:spcAft>
-              <a:defRPr sz="1500" b="0">
-                <a:solidFill>
-                  <a:srgbClr val="1A2836"/>
+              <a:defRPr sz="1150">
+                <a:solidFill>
+                  <a:srgbClr val="202B36"/>
                 </a:solidFill>
                 <a:latin typeface="Arial"/>
               </a:defRPr>
             </a:pPr>
             <a:r>
-              <a:t>MapLibre renders the tactical map; Three.js provides optional 3D entity views.</a:t>
-            </a:r>
-          </a:p>
+              <a:t>Roster, mission queue, map overlays and selected scenario.</a:t>
+            </a:r>
+          </a:p>
+        </p:txBody>
+      </p:sp>
+      <p:sp>
+        <p:nvSpPr>
+          <p:cNvPr id="17417" name="Oval 17416"/>
+          <p:cNvSpPr/>
+          <p:nvPr/>
+        </p:nvSpPr>
+        <p:spPr>
+          <a:xfrm>
+            <a:off x="676656" y="3218688"/>
+            <a:ext cx="384048" cy="384048"/>
+          </a:xfrm>
+          <a:prstGeom prst="ellipse">
+            <a:avLst/>
+          </a:prstGeom>
+          <a:solidFill>
+            <a:srgbClr val="224D80"/>
+          </a:solidFill>
+          <a:ln>
+            <a:noFill/>
+          </a:ln>
+        </p:spPr>
+        <p:style>
+          <a:lnRef idx="1">
+            <a:schemeClr val="accent1"/>
+          </a:lnRef>
+          <a:fillRef idx="3">
+            <a:schemeClr val="accent1"/>
+          </a:fillRef>
+          <a:effectRef idx="2">
+            <a:schemeClr val="accent1"/>
+          </a:effectRef>
+          <a:fontRef idx="minor">
+            <a:schemeClr val="lt1"/>
+          </a:fontRef>
+        </p:style>
+        <p:txBody>
+          <a:bodyPr rtlCol="0" anchor="ctr" lIns="0" rIns="0" tIns="0" bIns="0"/>
+          <a:lstStyle/>
+          <a:p>
+            <a:pPr algn="ctr">
+              <a:defRPr sz="1100" b="1">
+                <a:solidFill>
+                  <a:srgbClr val="FFFFFF"/>
+                </a:solidFill>
+                <a:latin typeface="Arial"/>
+              </a:defRPr>
+            </a:pPr>
+            <a:r>
+              <a:t>03</a:t>
+            </a:r>
+          </a:p>
+        </p:txBody>
+      </p:sp>
+      <p:sp>
+        <p:nvSpPr>
+          <p:cNvPr id="17418" name="TextBox 17417"/>
+          <p:cNvSpPr txBox="1"/>
+          <p:nvPr/>
+        </p:nvSpPr>
+        <p:spPr>
+          <a:xfrm>
+            <a:off x="1225296" y="3209544"/>
+            <a:ext cx="4617720" cy="694944"/>
+          </a:xfrm>
+          <a:prstGeom prst="rect">
+            <a:avLst/>
+          </a:prstGeom>
+          <a:noFill/>
+        </p:spPr>
+        <p:txBody>
+          <a:bodyPr wrap="square" lIns="0" rIns="0" tIns="0" bIns="0">
+            <a:spAutoFit/>
+          </a:bodyPr>
+          <a:lstStyle/>
           <a:p>
             <a:pPr>
               <a:spcAft>
-                <a:spcPts val="400"/>
+                <a:spcPts val="200"/>
               </a:spcAft>
-              <a:defRPr sz="1500" b="0">
-                <a:solidFill>
-                  <a:srgbClr val="1A2836"/>
+              <a:defRPr sz="1300" b="1">
+                <a:solidFill>
+                  <a:srgbClr val="224D80"/>
                 </a:solidFill>
                 <a:latin typeface="Arial"/>
               </a:defRPr>
             </a:pPr>
             <a:r>
-              <a:t>The simulation records decisions, phases and outcomes for an exercise AAR.</a:t>
+              <a:t>CONSTRAINT CHECKS</a:t>
             </a:r>
           </a:p>
           <a:p>
             <a:pPr>
               <a:spcAft>
-                <a:spcPts val="400"/>
+                <a:spcPts val="0"/>
+              </a:spcAft>
+              <a:defRPr sz="1150">
+                <a:solidFill>
+                  <a:srgbClr val="202B36"/>
+                </a:solidFill>
+                <a:latin typeface="Arial"/>
+              </a:defRPr>
+            </a:pPr>
+            <a:r>
+              <a:t>Readiness, fuel, crew rest, weapon fit and range, route, airspace and weather.</a:t>
+            </a:r>
+          </a:p>
+        </p:txBody>
+      </p:sp>
+      <p:sp>
+        <p:nvSpPr>
+          <p:cNvPr id="17419" name="Oval 17418"/>
+          <p:cNvSpPr/>
+          <p:nvPr/>
+        </p:nvSpPr>
+        <p:spPr>
+          <a:xfrm>
+            <a:off x="676656" y="3941064"/>
+            <a:ext cx="384048" cy="384048"/>
+          </a:xfrm>
+          <a:prstGeom prst="ellipse">
+            <a:avLst/>
+          </a:prstGeom>
+          <a:solidFill>
+            <a:srgbClr val="224D80"/>
+          </a:solidFill>
+          <a:ln>
+            <a:noFill/>
+          </a:ln>
+        </p:spPr>
+        <p:style>
+          <a:lnRef idx="1">
+            <a:schemeClr val="accent1"/>
+          </a:lnRef>
+          <a:fillRef idx="3">
+            <a:schemeClr val="accent1"/>
+          </a:fillRef>
+          <a:effectRef idx="2">
+            <a:schemeClr val="accent1"/>
+          </a:effectRef>
+          <a:fontRef idx="minor">
+            <a:schemeClr val="lt1"/>
+          </a:fontRef>
+        </p:style>
+        <p:txBody>
+          <a:bodyPr rtlCol="0" anchor="ctr" lIns="0" rIns="0" tIns="0" bIns="0"/>
+          <a:lstStyle/>
+          <a:p>
+            <a:pPr algn="ctr">
+              <a:defRPr sz="1100" b="1">
+                <a:solidFill>
+                  <a:srgbClr val="FFFFFF"/>
+                </a:solidFill>
+                <a:latin typeface="Arial"/>
+              </a:defRPr>
+            </a:pPr>
+            <a:r>
+              <a:t>04</a:t>
+            </a:r>
+          </a:p>
+        </p:txBody>
+      </p:sp>
+      <p:sp>
+        <p:nvSpPr>
+          <p:cNvPr id="17420" name="TextBox 17419"/>
+          <p:cNvSpPr txBox="1"/>
+          <p:nvPr/>
+        </p:nvSpPr>
+        <p:spPr>
+          <a:xfrm>
+            <a:off x="1225296" y="3931920"/>
+            <a:ext cx="4617720" cy="694944"/>
+          </a:xfrm>
+          <a:prstGeom prst="rect">
+            <a:avLst/>
+          </a:prstGeom>
+          <a:noFill/>
+        </p:spPr>
+        <p:txBody>
+          <a:bodyPr wrap="square" lIns="0" rIns="0" tIns="0" bIns="0">
+            <a:spAutoFit/>
+          </a:bodyPr>
+          <a:lstStyle/>
+          <a:p>
+            <a:pPr>
+              <a:spcAft>
+                <a:spcPts val="200"/>
               </a:spcAft>
               <a:defRPr sz="1300" b="1">
                 <a:solidFill>
@@ -6645,29 +7033,297 @@
               </a:defRPr>
             </a:pPr>
             <a:r>
-              <a:t>No machine learning model or operational order export is implemented.</a:t>
+              <a:t>COA RANKING</a:t>
+            </a:r>
+          </a:p>
+          <a:p>
+            <a:pPr>
+              <a:spcAft>
+                <a:spcPts val="0"/>
+              </a:spcAft>
+              <a:defRPr sz="1150">
+                <a:solidFill>
+                  <a:srgbClr val="202B36"/>
+                </a:solidFill>
+                <a:latin typeface="Arial"/>
+              </a:defRPr>
+            </a:pPr>
+            <a:r>
+              <a:t>Weighted rules compare aggressive, balanced and conservative options.</a:t>
+            </a:r>
+          </a:p>
+        </p:txBody>
+      </p:sp>
+      <p:sp>
+        <p:nvSpPr>
+          <p:cNvPr id="17421" name="Oval 17420"/>
+          <p:cNvSpPr/>
+          <p:nvPr/>
+        </p:nvSpPr>
+        <p:spPr>
+          <a:xfrm>
+            <a:off x="676656" y="4663440"/>
+            <a:ext cx="384048" cy="384048"/>
+          </a:xfrm>
+          <a:prstGeom prst="ellipse">
+            <a:avLst/>
+          </a:prstGeom>
+          <a:solidFill>
+            <a:srgbClr val="224D80"/>
+          </a:solidFill>
+          <a:ln>
+            <a:noFill/>
+          </a:ln>
+        </p:spPr>
+        <p:style>
+          <a:lnRef idx="1">
+            <a:schemeClr val="accent1"/>
+          </a:lnRef>
+          <a:fillRef idx="3">
+            <a:schemeClr val="accent1"/>
+          </a:fillRef>
+          <a:effectRef idx="2">
+            <a:schemeClr val="accent1"/>
+          </a:effectRef>
+          <a:fontRef idx="minor">
+            <a:schemeClr val="lt1"/>
+          </a:fontRef>
+        </p:style>
+        <p:txBody>
+          <a:bodyPr rtlCol="0" anchor="ctr" lIns="0" rIns="0" tIns="0" bIns="0"/>
+          <a:lstStyle/>
+          <a:p>
+            <a:pPr algn="ctr">
+              <a:defRPr sz="1100" b="1">
+                <a:solidFill>
+                  <a:srgbClr val="FFFFFF"/>
+                </a:solidFill>
+                <a:latin typeface="Arial"/>
+              </a:defRPr>
+            </a:pPr>
+            <a:r>
+              <a:t>05</a:t>
+            </a:r>
+          </a:p>
+        </p:txBody>
+      </p:sp>
+      <p:sp>
+        <p:nvSpPr>
+          <p:cNvPr id="17422" name="TextBox 17421"/>
+          <p:cNvSpPr txBox="1"/>
+          <p:nvPr/>
+        </p:nvSpPr>
+        <p:spPr>
+          <a:xfrm>
+            <a:off x="1225296" y="4654296"/>
+            <a:ext cx="4617720" cy="694944"/>
+          </a:xfrm>
+          <a:prstGeom prst="rect">
+            <a:avLst/>
+          </a:prstGeom>
+          <a:noFill/>
+        </p:spPr>
+        <p:txBody>
+          <a:bodyPr wrap="square" lIns="0" rIns="0" tIns="0" bIns="0">
+            <a:spAutoFit/>
+          </a:bodyPr>
+          <a:lstStyle/>
+          <a:p>
+            <a:pPr>
+              <a:spcAft>
+                <a:spcPts val="200"/>
+              </a:spcAft>
+              <a:defRPr sz="1300" b="1">
+                <a:solidFill>
+                  <a:srgbClr val="224D80"/>
+                </a:solidFill>
+                <a:latin typeface="Arial"/>
+              </a:defRPr>
+            </a:pPr>
+            <a:r>
+              <a:t>HUMAN REVIEW</a:t>
+            </a:r>
+          </a:p>
+          <a:p>
+            <a:pPr>
+              <a:spcAft>
+                <a:spcPts val="0"/>
+              </a:spcAft>
+              <a:defRPr sz="1150">
+                <a:solidFill>
+                  <a:srgbClr val="202B36"/>
+                </a:solidFill>
+                <a:latin typeface="Arial"/>
+              </a:defRPr>
+            </a:pPr>
+            <a:r>
+              <a:t>Review the briefing; approve or reject local exercise execution.</a:t>
+            </a:r>
+          </a:p>
+        </p:txBody>
+      </p:sp>
+      <p:sp>
+        <p:nvSpPr>
+          <p:cNvPr id="17423" name="Oval 17422"/>
+          <p:cNvSpPr/>
+          <p:nvPr/>
+        </p:nvSpPr>
+        <p:spPr>
+          <a:xfrm>
+            <a:off x="676656" y="5385816"/>
+            <a:ext cx="384048" cy="384048"/>
+          </a:xfrm>
+          <a:prstGeom prst="ellipse">
+            <a:avLst/>
+          </a:prstGeom>
+          <a:solidFill>
+            <a:srgbClr val="224D80"/>
+          </a:solidFill>
+          <a:ln>
+            <a:noFill/>
+          </a:ln>
+        </p:spPr>
+        <p:style>
+          <a:lnRef idx="1">
+            <a:schemeClr val="accent1"/>
+          </a:lnRef>
+          <a:fillRef idx="3">
+            <a:schemeClr val="accent1"/>
+          </a:fillRef>
+          <a:effectRef idx="2">
+            <a:schemeClr val="accent1"/>
+          </a:effectRef>
+          <a:fontRef idx="minor">
+            <a:schemeClr val="lt1"/>
+          </a:fontRef>
+        </p:style>
+        <p:txBody>
+          <a:bodyPr rtlCol="0" anchor="ctr" lIns="0" rIns="0" tIns="0" bIns="0"/>
+          <a:lstStyle/>
+          <a:p>
+            <a:pPr algn="ctr">
+              <a:defRPr sz="1100" b="1">
+                <a:solidFill>
+                  <a:srgbClr val="FFFFFF"/>
+                </a:solidFill>
+                <a:latin typeface="Arial"/>
+              </a:defRPr>
+            </a:pPr>
+            <a:r>
+              <a:t>06</a:t>
+            </a:r>
+          </a:p>
+        </p:txBody>
+      </p:sp>
+      <p:sp>
+        <p:nvSpPr>
+          <p:cNvPr id="17424" name="TextBox 17423"/>
+          <p:cNvSpPr txBox="1"/>
+          <p:nvPr/>
+        </p:nvSpPr>
+        <p:spPr>
+          <a:xfrm>
+            <a:off x="1225296" y="5376672"/>
+            <a:ext cx="4617720" cy="694944"/>
+          </a:xfrm>
+          <a:prstGeom prst="rect">
+            <a:avLst/>
+          </a:prstGeom>
+          <a:noFill/>
+        </p:spPr>
+        <p:txBody>
+          <a:bodyPr wrap="square" lIns="0" rIns="0" tIns="0" bIns="0">
+            <a:spAutoFit/>
+          </a:bodyPr>
+          <a:lstStyle/>
+          <a:p>
+            <a:pPr>
+              <a:spcAft>
+                <a:spcPts val="200"/>
+              </a:spcAft>
+              <a:defRPr sz="1300" b="1">
+                <a:solidFill>
+                  <a:srgbClr val="224D80"/>
+                </a:solidFill>
+                <a:latin typeface="Arial"/>
+              </a:defRPr>
+            </a:pPr>
+            <a:r>
+              <a:t>SIMULATED RUN + AAR</a:t>
+            </a:r>
+          </a:p>
+          <a:p>
+            <a:pPr>
+              <a:spcAft>
+                <a:spcPts val="0"/>
+              </a:spcAft>
+              <a:defRPr sz="1150">
+                <a:solidFill>
+                  <a:srgbClr val="202B36"/>
+                </a:solidFill>
+                <a:latin typeface="Arial"/>
+              </a:defRPr>
+            </a:pPr>
+            <a:r>
+              <a:t>Modeled phases, decision prompts, event history and exercise outcome.</a:t>
+            </a:r>
+          </a:p>
+        </p:txBody>
+      </p:sp>
+      <p:sp>
+        <p:nvSpPr>
+          <p:cNvPr id="17425" name="TextBox 17424"/>
+          <p:cNvSpPr txBox="1"/>
+          <p:nvPr/>
+        </p:nvSpPr>
+        <p:spPr>
+          <a:xfrm>
+            <a:off x="6236208" y="1444752"/>
+            <a:ext cx="5358384" cy="256032"/>
+          </a:xfrm>
+          <a:prstGeom prst="rect">
+            <a:avLst/>
+          </a:prstGeom>
+          <a:noFill/>
+        </p:spPr>
+        <p:txBody>
+          <a:bodyPr wrap="none" lIns="0" rIns="0" tIns="0" bIns="0">
+            <a:spAutoFit/>
+          </a:bodyPr>
+          <a:lstStyle/>
+          <a:p>
+            <a:pPr>
+              <a:defRPr sz="1300" b="1">
+                <a:solidFill>
+                  <a:srgbClr val="224D80"/>
+                </a:solidFill>
+                <a:latin typeface="Arial"/>
+              </a:defRPr>
+            </a:pPr>
+            <a:r>
+              <a:t>PROTOTYPE EVIDENCE</a:t>
             </a:r>
           </a:p>
         </p:txBody>
       </p:sp>
       <p:pic>
         <p:nvPicPr>
-          <p:cNvPr id="17411" name="Picture 17410" descr="19-map-threat-detail.png"/>
+          <p:cNvPr id="17426" name="Picture 17425" descr="image.png"/>
           <p:cNvPicPr>
             <a:picLocks noChangeAspect="1"/>
           </p:cNvPicPr>
           <p:nvPr/>
         </p:nvPicPr>
         <p:blipFill>
-          <a:blip r:embed="rId4"/>
+          <a:blip r:embed="rId5"/>
           <a:stretch>
             <a:fillRect/>
           </a:stretch>
         </p:blipFill>
         <p:spPr>
           <a:xfrm>
-            <a:off x="5989320" y="2514600"/>
-            <a:ext cx="5212080" cy="2931795"/>
+            <a:off x="6236208" y="1773936"/>
+            <a:ext cx="5358384" cy="3014091"/>
           </a:xfrm>
           <a:prstGeom prst="rect">
             <a:avLst/>
@@ -6676,14 +7332,14 @@
       </p:pic>
       <p:sp>
         <p:nvSpPr>
-          <p:cNvPr id="17412" name="TextBox 17411"/>
+          <p:cNvPr id="17427" name="TextBox 17426"/>
           <p:cNvSpPr txBox="1"/>
           <p:nvPr/>
         </p:nvSpPr>
         <p:spPr>
           <a:xfrm>
-            <a:off x="5989320" y="5519547"/>
-            <a:ext cx="5212080" cy="320040"/>
+            <a:off x="6236208" y="4818888"/>
+            <a:ext cx="5358384" cy="201168"/>
           </a:xfrm>
           <a:prstGeom prst="rect">
             <a:avLst/>
@@ -6691,24 +7347,165 @@
           <a:noFill/>
         </p:spPr>
         <p:txBody>
-          <a:bodyPr wrap="square" lIns="18288" rIns="36576" tIns="18288" bIns="18288">
+          <a:bodyPr wrap="none" lIns="0" rIns="0" tIns="0" bIns="0">
             <a:spAutoFit/>
           </a:bodyPr>
           <a:lstStyle/>
           <a:p>
             <a:pPr>
-              <a:spcAft>
-                <a:spcPts val="400"/>
-              </a:spcAft>
-              <a:defRPr sz="1000" b="0">
-                <a:solidFill>
-                  <a:srgbClr val="556370"/>
+              <a:defRPr sz="1000">
+                <a:solidFill>
+                  <a:srgbClr val="546370"/>
                 </a:solidFill>
                 <a:latin typeface="Arial"/>
               </a:defRPr>
             </a:pPr>
             <a:r>
-              <a:t>Tactical map · exercise threat and route context</a:t>
+              <a:t>Prototype capture | Simulated exercise data</a:t>
+            </a:r>
+          </a:p>
+        </p:txBody>
+      </p:sp>
+      <p:sp>
+        <p:nvSpPr>
+          <p:cNvPr id="17428" name="TextBox 17427"/>
+          <p:cNvSpPr txBox="1"/>
+          <p:nvPr/>
+        </p:nvSpPr>
+        <p:spPr>
+          <a:xfrm>
+            <a:off x="6236208" y="5102352"/>
+            <a:ext cx="1225296" cy="219456"/>
+          </a:xfrm>
+          <a:prstGeom prst="rect">
+            <a:avLst/>
+          </a:prstGeom>
+          <a:noFill/>
+        </p:spPr>
+        <p:txBody>
+          <a:bodyPr wrap="none" lIns="0" rIns="0" tIns="0" bIns="0">
+            <a:spAutoFit/>
+          </a:bodyPr>
+          <a:lstStyle/>
+          <a:p>
+            <a:pPr>
+              <a:defRPr sz="1050" b="1">
+                <a:solidFill>
+                  <a:srgbClr val="1B7571"/>
+                </a:solidFill>
+                <a:latin typeface="Arial"/>
+              </a:defRPr>
+            </a:pPr>
+            <a:r>
+              <a:t>STACK</a:t>
+            </a:r>
+          </a:p>
+        </p:txBody>
+      </p:sp>
+      <p:sp>
+        <p:nvSpPr>
+          <p:cNvPr id="17429" name="TextBox 17428"/>
+          <p:cNvSpPr txBox="1"/>
+          <p:nvPr/>
+        </p:nvSpPr>
+        <p:spPr>
+          <a:xfrm>
+            <a:off x="7498079" y="5093208"/>
+            <a:ext cx="4096512" cy="420624"/>
+          </a:xfrm>
+          <a:prstGeom prst="rect">
+            <a:avLst/>
+          </a:prstGeom>
+          <a:noFill/>
+        </p:spPr>
+        <p:txBody>
+          <a:bodyPr wrap="square" lIns="0" rIns="0" tIns="0" bIns="0">
+            <a:spAutoFit/>
+          </a:bodyPr>
+          <a:lstStyle/>
+          <a:p>
+            <a:pPr>
+              <a:defRPr sz="950">
+                <a:solidFill>
+                  <a:srgbClr val="202B36"/>
+                </a:solidFill>
+                <a:latin typeface="Arial"/>
+              </a:defRPr>
+            </a:pPr>
+            <a:r>
+              <a:t>Svelte 5 + TypeScript + Vite | MapLibre + Turf | Three.js + Threlte</a:t>
+            </a:r>
+          </a:p>
+        </p:txBody>
+      </p:sp>
+      <p:sp>
+        <p:nvSpPr>
+          <p:cNvPr id="17430" name="TextBox 17429"/>
+          <p:cNvSpPr txBox="1"/>
+          <p:nvPr/>
+        </p:nvSpPr>
+        <p:spPr>
+          <a:xfrm>
+            <a:off x="6236208" y="5504688"/>
+            <a:ext cx="1225296" cy="219456"/>
+          </a:xfrm>
+          <a:prstGeom prst="rect">
+            <a:avLst/>
+          </a:prstGeom>
+          <a:noFill/>
+        </p:spPr>
+        <p:txBody>
+          <a:bodyPr wrap="none" lIns="0" rIns="0" tIns="0" bIns="0">
+            <a:spAutoFit/>
+          </a:bodyPr>
+          <a:lstStyle/>
+          <a:p>
+            <a:pPr>
+              <a:defRPr sz="1050" b="1">
+                <a:solidFill>
+                  <a:srgbClr val="1B7571"/>
+                </a:solidFill>
+                <a:latin typeface="Arial"/>
+              </a:defRPr>
+            </a:pPr>
+            <a:r>
+              <a:t>SCOPE</a:t>
+            </a:r>
+          </a:p>
+        </p:txBody>
+      </p:sp>
+      <p:sp>
+        <p:nvSpPr>
+          <p:cNvPr id="17431" name="TextBox 17430"/>
+          <p:cNvSpPr txBox="1"/>
+          <p:nvPr/>
+        </p:nvSpPr>
+        <p:spPr>
+          <a:xfrm>
+            <a:off x="7498079" y="5495544"/>
+            <a:ext cx="4096512" cy="420624"/>
+          </a:xfrm>
+          <a:prstGeom prst="rect">
+            <a:avLst/>
+          </a:prstGeom>
+          <a:noFill/>
+        </p:spPr>
+        <p:txBody>
+          <a:bodyPr wrap="square" lIns="0" rIns="0" tIns="0" bIns="0">
+            <a:spAutoFit/>
+          </a:bodyPr>
+          <a:lstStyle/>
+          <a:p>
+            <a:pPr>
+              <a:defRPr sz="1050">
+                <a:solidFill>
+                  <a:srgbClr val="202B36"/>
+                </a:solidFill>
+                <a:latin typeface="Arial"/>
+              </a:defRPr>
+            </a:pPr>
+            <a:r>
+              <a:t>Seeded feeds and illustrative outcomes. No live IACCS/sensor links or operational ATO export.</a:t>
             </a:r>
           </a:p>
         </p:txBody>

</xml_diff>